<commit_message>
Physics deck: apply the glyph-safe symbol replacements the previous commit announced (the patch had aborted on console encoding)
</commit_message>
<xml_diff>
--- a/docs/presentation/KSTAR_CES_물리근거.pptx
+++ b/docs/presentation/KSTAR_CES_물리근거.pptx
@@ -11254,7 +11254,7 @@
                 <a:solidFill>
                   <a:srgbClr val="2E9E5B"/>
                 </a:solidFill>
-                <a:latin typeface="Consolas"/>
+                <a:latin typeface="Malgun Gothic"/>
               </a:rPr>
               <a:t>1.27배</a:t>
             </a:r>
@@ -11299,7 +11299,7 @@
                 <a:solidFill>
                   <a:srgbClr val="C0392B"/>
                 </a:solidFill>
-                <a:latin typeface="Consolas"/>
+                <a:latin typeface="Malgun Gothic"/>
               </a:rPr>
               <a:t>0.99배</a:t>
             </a:r>
@@ -11756,7 +11756,7 @@
                 </a:solidFill>
                 <a:latin typeface="Malgun Gothic"/>
               </a:rPr>
-              <a:t>Tᵢ의 ELM 붕괴는 계단이라 κ_T ≈ 1.03인데 V_rot의 토크 변화는 램프라 κ_V = Δ/2τ_φ = 0.056이다. 같은 진폭이라도 회수 가능한 에너지가 18분의 1이다.</a:t>
+              <a:t>Tᵢ의 ELM 붕괴는 계단이라 κ_T ~ 1.03인데 V_rot의 토크 변화는 램프라 κ_V = Δ/2τ_φ = 0.056이다. 같은 진폭이라도 회수 가능한 에너지가 18분의 1이다.</a:t>
             </a:r>
           </a:p>
         </p:txBody>
@@ -14787,7 +14787,7 @@
                 <a:solidFill>
                   <a:srgbClr val="222B35"/>
                 </a:solidFill>
-                <a:latin typeface="Consolas"/>
+                <a:latin typeface="Malgun Gothic"/>
               </a:rPr>
               <a:t>0.05배 vs 5.8배</a:t>
             </a:r>
@@ -18284,7 +18284,7 @@
                 <a:solidFill>
                   <a:srgbClr val="222B35"/>
                 </a:solidFill>
-                <a:latin typeface="Consolas"/>
+                <a:latin typeface="Malgun Gothic"/>
               </a:rPr>
               <a:t>1,823,490의 98.2 %</a:t>
             </a:r>
@@ -25459,7 +25459,7 @@
                 </a:solidFill>
                 <a:latin typeface="Malgun Gothic"/>
               </a:rPr>
-              <a:t>플라즈마 거동 물리 12장 · CES를 예측하는 두 경로 · Pr ≈ 1 · EHO Doppler</a:t>
+              <a:t>플라즈마 거동 물리 12장 · CES를 예측하는 두 경로 · Pr ~ 1 · EHO Doppler</a:t>
             </a:r>
           </a:p>
         </p:txBody>
@@ -33176,7 +33176,7 @@
                 </a:solidFill>
                 <a:latin typeface="Malgun Gothic"/>
               </a:rPr>
-              <a:t>τ_φ ≈ τ_E; 데이터 89 ms → Pr ≈ 1</a:t>
+              <a:t>τ_φ ~ τ_E; 데이터 89 ms → Pr ~ 1</a:t>
             </a:r>
           </a:p>
         </p:txBody>
@@ -33489,7 +33489,7 @@
                 </a:solidFill>
                 <a:latin typeface="Malgun Gothic"/>
               </a:rPr>
-              <a:t>ELM 붕괴: ms 이하 계단, κ_T ≈ 1.03</a:t>
+              <a:t>ELM 붕괴: ms 이하 계단, κ_T ~ 1.03</a:t>
             </a:r>
           </a:p>
         </p:txBody>
@@ -34692,7 +34692,7 @@
                 </a:solidFill>
                 <a:latin typeface="Malgun Gothic"/>
               </a:rPr>
-              <a:t>skill = f_I · r_I - (1-f_I) · ℓ_B   — 천이 행의 기준선 SSE 비중 × 그 행의 회수율, 빼기 본류 손실. 4분할에서 10⁻¹⁶ 정확도로 성립.</a:t>
+              <a:t>skill = f_I · r_I - (1-f_I) · ℓ_B   — 천이 행의 기준선 SSE 비중 × 그 행의 회수율, 빼기 본류 손실. 4분할에서 1e-16 정확도로 성립.</a:t>
             </a:r>
           </a:p>
         </p:txBody>
@@ -36406,7 +36406,7 @@
                 </a:solidFill>
                 <a:latin typeface="Malgun Gothic"/>
               </a:rPr>
-              <a:t>문맥 ≈ 1.5 τ_rec 필요</a:t>
+              <a:t>문맥 ~ 1.5 τ_rec 필요</a:t>
             </a:r>
           </a:p>
         </p:txBody>

</xml_diff>